<commit_message>
Major Update: The application now prefers **Supabase** for shared cross-user visibility and uses IndexedDB as a fallback when remote access is unavailable
</commit_message>
<xml_diff>
--- a/OmniPay_System_Presentation.pptx
+++ b/OmniPay_System_Presentation.pptx
@@ -4762,43 +4762,43 @@
               </a:defRPr>
             </a:pPr>
             <a:r>
-              <a:t>• Stored in browser IndexedDB (local machine only)</a:t>
-            </a:r>
-          </a:p>
-          <a:p>
-            <a:pPr>
-              <a:spcBef>
-                <a:spcPts val="800"/>
-              </a:spcBef>
-              <a:spcAft>
-                <a:spcPts val="800"/>
-              </a:spcAft>
-              <a:defRPr sz="1800">
-                <a:solidFill>
-                  <a:srgbClr val="000000"/>
-                </a:solidFill>
-              </a:defRPr>
-            </a:pPr>
-            <a:r>
-              <a:t>• No data transmitted to external servers</a:t>
-            </a:r>
-          </a:p>
-          <a:p>
-            <a:pPr>
-              <a:spcBef>
-                <a:spcPts val="800"/>
-              </a:spcBef>
-              <a:spcAft>
-                <a:spcPts val="800"/>
-              </a:spcAft>
-              <a:defRPr sz="1800">
-                <a:solidFill>
-                  <a:srgbClr val="000000"/>
-                </a:solidFill>
-              </a:defRPr>
-            </a:pPr>
-            <a:r>
-              <a:t>• Currently single-user per browser instance</a:t>
+              <a:t>• Stored through Supabase when available, with IndexedDB fallback</a:t>
+            </a:r>
+          </a:p>
+          <a:p>
+            <a:pPr>
+              <a:spcBef>
+                <a:spcPts val="800"/>
+              </a:spcBef>
+              <a:spcAft>
+                <a:spcPts val="800"/>
+              </a:spcAft>
+              <a:defRPr sz="1800">
+                <a:solidFill>
+                  <a:srgbClr val="000000"/>
+                </a:solidFill>
+              </a:defRPr>
+            </a:pPr>
+            <a:r>
+              <a:t>• Supports shared visibility for authorized users across browsers</a:t>
+            </a:r>
+          </a:p>
+          <a:p>
+            <a:pPr>
+              <a:spcBef>
+                <a:spcPts val="800"/>
+              </a:spcBef>
+              <a:spcAft>
+                <a:spcPts val="800"/>
+              </a:spcAft>
+              <a:defRPr sz="1800">
+                <a:solidFill>
+                  <a:srgbClr val="000000"/>
+                </a:solidFill>
+              </a:defRPr>
+            </a:pPr>
+            <a:r>
+              <a:t>• Keeps audit history and operational records available for review</a:t>
             </a:r>
           </a:p>
           <a:p>
@@ -4849,61 +4849,61 @@
               </a:defRPr>
             </a:pPr>
             <a:r>
-              <a:t>• Export inventory weekly to Excel</a:t>
-            </a:r>
-          </a:p>
-          <a:p>
-            <a:pPr>
-              <a:spcBef>
-                <a:spcPts val="800"/>
-              </a:spcBef>
-              <a:spcAft>
-                <a:spcPts val="800"/>
-              </a:spcAft>
-              <a:defRPr sz="1800">
-                <a:solidFill>
-                  <a:srgbClr val="000000"/>
-                </a:solidFill>
-              </a:defRPr>
-            </a:pPr>
-            <a:r>
-              <a:t>• Archive reconciliation logs monthly</a:t>
-            </a:r>
-          </a:p>
-          <a:p>
-            <a:pPr>
-              <a:spcBef>
-                <a:spcPts val="800"/>
-              </a:spcBef>
-              <a:spcAft>
-                <a:spcPts val="800"/>
-              </a:spcAft>
-              <a:defRPr sz="1800">
-                <a:solidFill>
-                  <a:srgbClr val="000000"/>
-                </a:solidFill>
-              </a:defRPr>
-            </a:pPr>
-            <a:r>
-              <a:t>• Date-stamp all exported files</a:t>
-            </a:r>
-          </a:p>
-          <a:p>
-            <a:pPr>
-              <a:spcBef>
-                <a:spcPts val="800"/>
-              </a:spcBef>
-              <a:spcAft>
-                <a:spcPts val="800"/>
-              </a:spcAft>
-              <a:defRPr sz="1800">
-                <a:solidFill>
-                  <a:srgbClr val="000000"/>
-                </a:solidFill>
-              </a:defRPr>
-            </a:pPr>
-            <a:r>
-              <a:t>• Keep offline copies for audit trail</a:t>
+              <a:t>• Export inventory and logs regularly to Excel</a:t>
+            </a:r>
+          </a:p>
+          <a:p>
+            <a:pPr>
+              <a:spcBef>
+                <a:spcPts val="800"/>
+              </a:spcBef>
+              <a:spcAft>
+                <a:spcPts val="800"/>
+              </a:spcAft>
+              <a:defRPr sz="1800">
+                <a:solidFill>
+                  <a:srgbClr val="000000"/>
+                </a:solidFill>
+              </a:defRPr>
+            </a:pPr>
+            <a:r>
+              <a:t>• Keep source import files for traceability</a:t>
+            </a:r>
+          </a:p>
+          <a:p>
+            <a:pPr>
+              <a:spcBef>
+                <a:spcPts val="800"/>
+              </a:spcBef>
+              <a:spcAft>
+                <a:spcPts val="800"/>
+              </a:spcAft>
+              <a:defRPr sz="1800">
+                <a:solidFill>
+                  <a:srgbClr val="000000"/>
+                </a:solidFill>
+              </a:defRPr>
+            </a:pPr>
+            <a:r>
+              <a:t>• Archive historical records for audit and reporting</a:t>
+            </a:r>
+          </a:p>
+          <a:p>
+            <a:pPr>
+              <a:spcBef>
+                <a:spcPts val="800"/>
+              </a:spcBef>
+              <a:spcAft>
+                <a:spcPts val="800"/>
+              </a:spcAft>
+              <a:defRPr sz="1800">
+                <a:solidFill>
+                  <a:srgbClr val="000000"/>
+                </a:solidFill>
+              </a:defRPr>
+            </a:pPr>
+            <a:r>
+              <a:t>• Validate shared access settings for team workflows</a:t>
             </a:r>
           </a:p>
         </p:txBody>
@@ -5674,61 +5674,61 @@
               </a:defRPr>
             </a:pPr>
             <a:r>
-              <a:t>• Master Inventory: Persists until cleared</a:t>
-            </a:r>
-          </a:p>
-          <a:p>
-            <a:pPr>
-              <a:spcBef>
-                <a:spcPts val="800"/>
-              </a:spcBef>
-              <a:spcAft>
-                <a:spcPts val="800"/>
-              </a:spcAft>
-              <a:defRPr sz="1800">
-                <a:solidFill>
-                  <a:srgbClr val="000000"/>
-                </a:solidFill>
-              </a:defRPr>
-            </a:pPr>
-            <a:r>
-              <a:t>• Portal Records: Latest import stored</a:t>
-            </a:r>
-          </a:p>
-          <a:p>
-            <a:pPr>
-              <a:spcBef>
-                <a:spcPts val="800"/>
-              </a:spcBef>
-              <a:spcAft>
-                <a:spcPts val="800"/>
-              </a:spcAft>
-              <a:defRPr sz="1800">
-                <a:solidFill>
-                  <a:srgbClr val="000000"/>
-                </a:solidFill>
-              </a:defRPr>
-            </a:pPr>
-            <a:r>
-              <a:t>• Reconciliation Logs: Last 500 kept, older auto-removed</a:t>
-            </a:r>
-          </a:p>
-          <a:p>
-            <a:pPr>
-              <a:spcBef>
-                <a:spcPts val="800"/>
-              </a:spcBef>
-              <a:spcAft>
-                <a:spcPts val="800"/>
-              </a:spcAft>
-              <a:defRPr sz="1800">
-                <a:solidFill>
-                  <a:srgbClr val="000000"/>
-                </a:solidFill>
-              </a:defRPr>
-            </a:pPr>
-            <a:r>
-              <a:t>• Vendor Data: Persists indefinitely</a:t>
+              <a:t>• Master Inventory: Persists in shared storage and fallback storage</a:t>
+            </a:r>
+          </a:p>
+          <a:p>
+            <a:pPr>
+              <a:spcBef>
+                <a:spcPts val="800"/>
+              </a:spcBef>
+              <a:spcAft>
+                <a:spcPts val="800"/>
+              </a:spcAft>
+              <a:defRPr sz="1800">
+                <a:solidFill>
+                  <a:srgbClr val="000000"/>
+                </a:solidFill>
+              </a:defRPr>
+            </a:pPr>
+            <a:r>
+              <a:t>• Portal Records: Latest import stored for current workflows</a:t>
+            </a:r>
+          </a:p>
+          <a:p>
+            <a:pPr>
+              <a:spcBef>
+                <a:spcPts val="800"/>
+              </a:spcBef>
+              <a:spcAft>
+                <a:spcPts val="800"/>
+              </a:spcAft>
+              <a:defRPr sz="1800">
+                <a:solidFill>
+                  <a:srgbClr val="000000"/>
+                </a:solidFill>
+              </a:defRPr>
+            </a:pPr>
+            <a:r>
+              <a:t>• Reconciliation Logs: Retained for review and audit tracking</a:t>
+            </a:r>
+          </a:p>
+          <a:p>
+            <a:pPr>
+              <a:spcBef>
+                <a:spcPts val="800"/>
+              </a:spcBef>
+              <a:spcAft>
+                <a:spcPts val="800"/>
+              </a:spcAft>
+              <a:defRPr sz="1800">
+                <a:solidFill>
+                  <a:srgbClr val="000000"/>
+                </a:solidFill>
+              </a:defRPr>
+            </a:pPr>
+            <a:r>
+              <a:t>• Vendor Data: Maintained for operational history</a:t>
             </a:r>
           </a:p>
           <a:p>
@@ -5779,61 +5779,43 @@
               </a:defRPr>
             </a:pPr>
             <a:r>
-              <a:t>• Data is local - no cloud transmission</a:t>
-            </a:r>
-          </a:p>
-          <a:p>
-            <a:pPr>
-              <a:spcBef>
-                <a:spcPts val="800"/>
-              </a:spcBef>
-              <a:spcAft>
-                <a:spcPts val="800"/>
-              </a:spcAft>
-              <a:defRPr sz="1800">
-                <a:solidFill>
-                  <a:srgbClr val="000000"/>
-                </a:solidFill>
-              </a:defRPr>
-            </a:pPr>
-            <a:r>
-              <a:t>• Clearing browser cache deletes all data</a:t>
-            </a:r>
-          </a:p>
-          <a:p>
-            <a:pPr>
-              <a:spcBef>
-                <a:spcPts val="800"/>
-              </a:spcBef>
-              <a:spcAft>
-                <a:spcPts val="800"/>
-              </a:spcAft>
-              <a:defRPr sz="1800">
-                <a:solidFill>
-                  <a:srgbClr val="000000"/>
-                </a:solidFill>
-              </a:defRPr>
-            </a:pPr>
-            <a:r>
-              <a:t>• No user authentication in v1.0 (future enhancement)</a:t>
-            </a:r>
-          </a:p>
-          <a:p>
-            <a:pPr>
-              <a:spcBef>
-                <a:spcPts val="800"/>
-              </a:spcBef>
-              <a:spcAft>
-                <a:spcPts val="800"/>
-              </a:spcAft>
-              <a:defRPr sz="1800">
-                <a:solidFill>
-                  <a:srgbClr val="000000"/>
-                </a:solidFill>
-              </a:defRPr>
-            </a:pPr>
-            <a:r>
-              <a:t>• Regular backups recommended</a:t>
+              <a:t>• Role-based access controls protect key workflows</a:t>
+            </a:r>
+          </a:p>
+          <a:p>
+            <a:pPr>
+              <a:spcBef>
+                <a:spcPts val="800"/>
+              </a:spcBef>
+              <a:spcAft>
+                <a:spcPts val="800"/>
+              </a:spcAft>
+              <a:defRPr sz="1800">
+                <a:solidFill>
+                  <a:srgbClr val="000000"/>
+                </a:solidFill>
+              </a:defRPr>
+            </a:pPr>
+            <a:r>
+              <a:t>• Shared storage is managed through Supabase policies</a:t>
+            </a:r>
+          </a:p>
+          <a:p>
+            <a:pPr>
+              <a:spcBef>
+                <a:spcPts val="800"/>
+              </a:spcBef>
+              <a:spcAft>
+                <a:spcPts val="800"/>
+              </a:spcAft>
+              <a:defRPr sz="1800">
+                <a:solidFill>
+                  <a:srgbClr val="000000"/>
+                </a:solidFill>
+              </a:defRPr>
+            </a:pPr>
+            <a:r>
+              <a:t>• Regular exports and validation are recommended for compliance</a:t>
             </a:r>
           </a:p>
         </p:txBody>
@@ -6282,166 +6264,148 @@
               </a:defRPr>
             </a:pPr>
             <a:r>
-              <a:t>Phase 2 - Multi-User Support:</a:t>
-            </a:r>
-          </a:p>
-          <a:p>
-            <a:pPr>
-              <a:spcBef>
-                <a:spcPts val="800"/>
-              </a:spcBef>
-              <a:spcAft>
-                <a:spcPts val="800"/>
-              </a:spcAft>
-              <a:defRPr sz="1800">
-                <a:solidFill>
-                  <a:srgbClr val="000000"/>
-                </a:solidFill>
-              </a:defRPr>
-            </a:pPr>
-            <a:r>
-              <a:t>• Server-backed database (AWS/GCP/Azure)</a:t>
-            </a:r>
-          </a:p>
-          <a:p>
-            <a:pPr>
-              <a:spcBef>
-                <a:spcPts val="800"/>
-              </a:spcBef>
-              <a:spcAft>
-                <a:spcPts val="800"/>
-              </a:spcAft>
-              <a:defRPr sz="1800">
-                <a:solidFill>
-                  <a:srgbClr val="000000"/>
-                </a:solidFill>
-              </a:defRPr>
-            </a:pPr>
-            <a:r>
-              <a:t>• User authentication &amp; role-based access</a:t>
-            </a:r>
-          </a:p>
-          <a:p>
-            <a:pPr>
-              <a:spcBef>
-                <a:spcPts val="800"/>
-              </a:spcBef>
-              <a:spcAft>
-                <a:spcPts val="800"/>
-              </a:spcAft>
-              <a:defRPr sz="1800">
-                <a:solidFill>
-                  <a:srgbClr val="000000"/>
-                </a:solidFill>
-              </a:defRPr>
-            </a:pPr>
-            <a:r>
-              <a:t>• Real-time data sync across devices</a:t>
-            </a:r>
-          </a:p>
-          <a:p>
-            <a:pPr>
-              <a:spcBef>
-                <a:spcPts val="800"/>
-              </a:spcBef>
-              <a:spcAft>
-                <a:spcPts val="800"/>
-              </a:spcAft>
-              <a:defRPr sz="1800">
-                <a:solidFill>
-                  <a:srgbClr val="000000"/>
-                </a:solidFill>
-              </a:defRPr>
-            </a:pPr>
-          </a:p>
-          <a:p>
-            <a:pPr>
-              <a:spcBef>
-                <a:spcPts val="800"/>
-              </a:spcBef>
-              <a:spcAft>
-                <a:spcPts val="800"/>
-              </a:spcAft>
-              <a:defRPr sz="1800">
-                <a:solidFill>
-                  <a:srgbClr val="000000"/>
-                </a:solidFill>
-              </a:defRPr>
-            </a:pPr>
-            <a:r>
-              <a:t>Phase 3 - Advanced Features:</a:t>
-            </a:r>
-          </a:p>
-          <a:p>
-            <a:pPr>
-              <a:spcBef>
-                <a:spcPts val="800"/>
-              </a:spcBef>
-              <a:spcAft>
-                <a:spcPts val="800"/>
-              </a:spcAft>
-              <a:defRPr sz="1800">
-                <a:solidFill>
-                  <a:srgbClr val="000000"/>
-                </a:solidFill>
-              </a:defRPr>
-            </a:pPr>
-            <a:r>
-              <a:t>• Mobile app for field tracking</a:t>
-            </a:r>
-          </a:p>
-          <a:p>
-            <a:pPr>
-              <a:spcBef>
-                <a:spcPts val="800"/>
-              </a:spcBef>
-              <a:spcAft>
-                <a:spcPts val="800"/>
-              </a:spcAft>
-              <a:defRPr sz="1800">
-                <a:solidFill>
-                  <a:srgbClr val="000000"/>
-                </a:solidFill>
-              </a:defRPr>
-            </a:pPr>
-            <a:r>
-              <a:t>• Automated email notifications</a:t>
-            </a:r>
-          </a:p>
-          <a:p>
-            <a:pPr>
-              <a:spcBef>
-                <a:spcPts val="800"/>
-              </a:spcBef>
-              <a:spcAft>
-                <a:spcPts val="800"/>
-              </a:spcAft>
-              <a:defRPr sz="1800">
-                <a:solidFill>
-                  <a:srgbClr val="000000"/>
-                </a:solidFill>
-              </a:defRPr>
-            </a:pPr>
-            <a:r>
-              <a:t>• Advanced analytics &amp; reporting</a:t>
-            </a:r>
-          </a:p>
-          <a:p>
-            <a:pPr>
-              <a:spcBef>
-                <a:spcPts val="800"/>
-              </a:spcBef>
-              <a:spcAft>
-                <a:spcPts val="800"/>
-              </a:spcAft>
-              <a:defRPr sz="1800">
-                <a:solidFill>
-                  <a:srgbClr val="000000"/>
-                </a:solidFill>
-              </a:defRPr>
-            </a:pPr>
-            <a:r>
-              <a:t>• Integration with accounting systems</a:t>
+              <a:t>Phase 2 - Advanced Operations:</a:t>
+            </a:r>
+          </a:p>
+          <a:p>
+            <a:pPr>
+              <a:spcBef>
+                <a:spcPts val="800"/>
+              </a:spcBef>
+              <a:spcAft>
+                <a:spcPts val="800"/>
+              </a:spcAft>
+              <a:defRPr sz="1800">
+                <a:solidFill>
+                  <a:srgbClr val="000000"/>
+                </a:solidFill>
+              </a:defRPr>
+            </a:pPr>
+            <a:r>
+              <a:t>• Expanded analytics and forecasting reports</a:t>
+            </a:r>
+          </a:p>
+          <a:p>
+            <a:pPr>
+              <a:spcBef>
+                <a:spcPts val="800"/>
+              </a:spcBef>
+              <a:spcAft>
+                <a:spcPts val="800"/>
+              </a:spcAft>
+              <a:defRPr sz="1800">
+                <a:solidFill>
+                  <a:srgbClr val="000000"/>
+                </a:solidFill>
+              </a:defRPr>
+            </a:pPr>
+            <a:r>
+              <a:t>• More automation for exception review workflows</a:t>
+            </a:r>
+          </a:p>
+          <a:p>
+            <a:pPr>
+              <a:spcBef>
+                <a:spcPts val="800"/>
+              </a:spcBef>
+              <a:spcAft>
+                <a:spcPts val="800"/>
+              </a:spcAft>
+              <a:defRPr sz="1800">
+                <a:solidFill>
+                  <a:srgbClr val="000000"/>
+                </a:solidFill>
+              </a:defRPr>
+            </a:pPr>
+            <a:r>
+              <a:t>• Stronger reporting for regional and vendor performance</a:t>
+            </a:r>
+          </a:p>
+          <a:p>
+            <a:pPr>
+              <a:spcBef>
+                <a:spcPts val="800"/>
+              </a:spcBef>
+              <a:spcAft>
+                <a:spcPts val="800"/>
+              </a:spcAft>
+              <a:defRPr sz="1800">
+                <a:solidFill>
+                  <a:srgbClr val="000000"/>
+                </a:solidFill>
+              </a:defRPr>
+            </a:pPr>
+          </a:p>
+          <a:p>
+            <a:pPr>
+              <a:spcBef>
+                <a:spcPts val="800"/>
+              </a:spcBef>
+              <a:spcAft>
+                <a:spcPts val="800"/>
+              </a:spcAft>
+              <a:defRPr sz="1800">
+                <a:solidFill>
+                  <a:srgbClr val="000000"/>
+                </a:solidFill>
+              </a:defRPr>
+            </a:pPr>
+            <a:r>
+              <a:t>Phase 3 - Integrations:</a:t>
+            </a:r>
+          </a:p>
+          <a:p>
+            <a:pPr>
+              <a:spcBef>
+                <a:spcPts val="800"/>
+              </a:spcBef>
+              <a:spcAft>
+                <a:spcPts val="800"/>
+              </a:spcAft>
+              <a:defRPr sz="1800">
+                <a:solidFill>
+                  <a:srgbClr val="000000"/>
+                </a:solidFill>
+              </a:defRPr>
+            </a:pPr>
+            <a:r>
+              <a:t>• Mobile support for field tracking</a:t>
+            </a:r>
+          </a:p>
+          <a:p>
+            <a:pPr>
+              <a:spcBef>
+                <a:spcPts val="800"/>
+              </a:spcBef>
+              <a:spcAft>
+                <a:spcPts val="800"/>
+              </a:spcAft>
+              <a:defRPr sz="1800">
+                <a:solidFill>
+                  <a:srgbClr val="000000"/>
+                </a:solidFill>
+              </a:defRPr>
+            </a:pPr>
+            <a:r>
+              <a:t>• Automated notifications and reminders</a:t>
+            </a:r>
+          </a:p>
+          <a:p>
+            <a:pPr>
+              <a:spcBef>
+                <a:spcPts val="800"/>
+              </a:spcBef>
+              <a:spcAft>
+                <a:spcPts val="800"/>
+              </a:spcAft>
+              <a:defRPr sz="1800">
+                <a:solidFill>
+                  <a:srgbClr val="000000"/>
+                </a:solidFill>
+              </a:defRPr>
+            </a:pPr>
+            <a:r>
+              <a:t>• Integration with downstream finance and audit tools</a:t>
             </a:r>
           </a:p>
         </p:txBody>
@@ -6580,25 +6544,43 @@
               </a:defRPr>
             </a:pPr>
             <a:r>
-              <a:t>• Browser-based POS terminal inventory management system</a:t>
-            </a:r>
-          </a:p>
-          <a:p>
-            <a:pPr>
-              <a:spcBef>
-                <a:spcPts val="800"/>
-              </a:spcBef>
-              <a:spcAft>
-                <a:spcPts val="800"/>
-              </a:spcAft>
-              <a:defRPr sz="1800">
-                <a:solidFill>
-                  <a:srgbClr val="000000"/>
-                </a:solidFill>
-              </a:defRPr>
-            </a:pPr>
-            <a:r>
-              <a:t>• Real-time dashboard with KPI tracking</a:t>
+              <a:t>• Shared POS terminal inventory workflow for admins and approved users</a:t>
+            </a:r>
+          </a:p>
+          <a:p>
+            <a:pPr>
+              <a:spcBef>
+                <a:spcPts val="800"/>
+              </a:spcBef>
+              <a:spcAft>
+                <a:spcPts val="800"/>
+              </a:spcAft>
+              <a:defRPr sz="1800">
+                <a:solidFill>
+                  <a:srgbClr val="000000"/>
+                </a:solidFill>
+              </a:defRPr>
+            </a:pPr>
+            <a:r>
+              <a:t>• Supabase-first storage with IndexedDB fallback for resilience</a:t>
+            </a:r>
+          </a:p>
+          <a:p>
+            <a:pPr>
+              <a:spcBef>
+                <a:spcPts val="800"/>
+              </a:spcBef>
+              <a:spcAft>
+                <a:spcPts val="800"/>
+              </a:spcAft>
+              <a:defRPr sz="1800">
+                <a:solidFill>
+                  <a:srgbClr val="000000"/>
+                </a:solidFill>
+              </a:defRPr>
+            </a:pPr>
+            <a:r>
+              <a:t>• Real-time dashboard with KPI tracking and charts</a:t>
             </a:r>
           </a:p>
           <a:p>
@@ -6634,43 +6616,25 @@
               </a:defRPr>
             </a:pPr>
             <a:r>
-              <a:t>• Vendor management with repair cost tracking</a:t>
-            </a:r>
-          </a:p>
-          <a:p>
-            <a:pPr>
-              <a:spcBef>
-                <a:spcPts val="800"/>
-              </a:spcBef>
-              <a:spcAft>
-                <a:spcPts val="800"/>
-              </a:spcAft>
-              <a:defRPr sz="1800">
-                <a:solidFill>
-                  <a:srgbClr val="000000"/>
-                </a:solidFill>
-              </a:defRPr>
-            </a:pPr>
-            <a:r>
-              <a:t>• Local data persistence ensuring offline access</a:t>
-            </a:r>
-          </a:p>
-          <a:p>
-            <a:pPr>
-              <a:spcBef>
-                <a:spcPts val="800"/>
-              </a:spcBef>
-              <a:spcAft>
-                <a:spcPts val="800"/>
-              </a:spcAft>
-              <a:defRPr sz="1800">
-                <a:solidFill>
-                  <a:srgbClr val="000000"/>
-                </a:solidFill>
-              </a:defRPr>
-            </a:pPr>
-            <a:r>
-              <a:t>• Built for scalability with planned multi-user server backend</a:t>
+              <a:t>• Vendor management, repair cost tracking, and fault uploads</a:t>
+            </a:r>
+          </a:p>
+          <a:p>
+            <a:pPr>
+              <a:spcBef>
+                <a:spcPts val="800"/>
+              </a:spcBef>
+              <a:spcAft>
+                <a:spcPts val="800"/>
+              </a:spcAft>
+              <a:defRPr sz="1800">
+                <a:solidFill>
+                  <a:srgbClr val="000000"/>
+                </a:solidFill>
+              </a:defRPr>
+            </a:pPr>
+            <a:r>
+              <a:t>• Large-upload support for thousands of records through chunked processing</a:t>
             </a:r>
           </a:p>
         </p:txBody>
@@ -6827,7 +6791,7 @@
               </a:defRPr>
             </a:pPr>
             <a:r>
-              <a:t>A: No, only for initial load. System works offline.</a:t>
+              <a:t>A: The app is best used with internet access for shared Supabase data, but fallback storage helps when needed.</a:t>
             </a:r>
           </a:p>
           <a:p>
@@ -6878,7 +6842,7 @@
               </a:defRPr>
             </a:pPr>
             <a:r>
-              <a:t>A: Browser IndexedDB on your local computer.</a:t>
+              <a:t>A: The app prefers Supabase and uses IndexedDB fallback when the shared storage layer is unavailable.</a:t>
             </a:r>
           </a:p>
           <a:p>
@@ -6929,7 +6893,7 @@
               </a:defRPr>
             </a:pPr>
             <a:r>
-              <a:t>A: Not yet (v1.0 is single-user). Multi-user in future.</a:t>
+              <a:t>A: Yes, authorized users can access shared records when the correct permissions and Supabase setup are in place.</a:t>
             </a:r>
           </a:p>
           <a:p>
@@ -6980,7 +6944,7 @@
               </a:defRPr>
             </a:pPr>
             <a:r>
-              <a:t>A: Data is deleted. Always export backups first.</a:t>
+              <a:t>A: Browser-only copies may be lost, so regular exports and shared storage checks are recommended.</a:t>
             </a:r>
           </a:p>
         </p:txBody>
@@ -7788,142 +7752,160 @@
               </a:defRPr>
             </a:pPr>
             <a:r>
-              <a:t>  → React 18.2 + TypeScript for type-safe UI components</a:t>
-            </a:r>
-          </a:p>
-          <a:p>
-            <a:pPr>
-              <a:spcBef>
-                <a:spcPts val="800"/>
-              </a:spcBef>
-              <a:spcAft>
-                <a:spcPts val="800"/>
-              </a:spcAft>
-              <a:defRPr sz="1800">
-                <a:solidFill>
-                  <a:srgbClr val="000000"/>
-                </a:solidFill>
-              </a:defRPr>
-            </a:pPr>
-          </a:p>
-          <a:p>
-            <a:pPr>
-              <a:spcBef>
-                <a:spcPts val="800"/>
-              </a:spcBef>
-              <a:spcAft>
-                <a:spcPts val="800"/>
-              </a:spcAft>
-              <a:defRPr sz="1800">
-                <a:solidFill>
-                  <a:srgbClr val="000000"/>
-                </a:solidFill>
-              </a:defRPr>
-            </a:pPr>
-            <a:r>
-              <a:t>State &amp; Routing Layer</a:t>
-            </a:r>
-          </a:p>
-          <a:p>
-            <a:pPr>
-              <a:spcBef>
-                <a:spcPts val="800"/>
-              </a:spcBef>
-              <a:spcAft>
-                <a:spcPts val="800"/>
-              </a:spcAft>
-              <a:defRPr sz="1800">
-                <a:solidFill>
-                  <a:srgbClr val="000000"/>
-                </a:solidFill>
-              </a:defRPr>
-            </a:pPr>
-            <a:r>
-              <a:t>  → React Router for seamless page navigation</a:t>
-            </a:r>
-          </a:p>
-          <a:p>
-            <a:pPr>
-              <a:spcBef>
-                <a:spcPts val="800"/>
-              </a:spcBef>
-              <a:spcAft>
-                <a:spcPts val="800"/>
-              </a:spcAft>
-              <a:defRPr sz="1800">
-                <a:solidFill>
-                  <a:srgbClr val="000000"/>
-                </a:solidFill>
-              </a:defRPr>
-            </a:pPr>
-          </a:p>
-          <a:p>
-            <a:pPr>
-              <a:spcBef>
-                <a:spcPts val="800"/>
-              </a:spcBef>
-              <a:spcAft>
-                <a:spcPts val="800"/>
-              </a:spcAft>
-              <a:defRPr sz="1800">
-                <a:solidFill>
-                  <a:srgbClr val="000000"/>
-                </a:solidFill>
-              </a:defRPr>
-            </a:pPr>
-            <a:r>
-              <a:t>Data Persistence Layer</a:t>
-            </a:r>
-          </a:p>
-          <a:p>
-            <a:pPr>
-              <a:spcBef>
-                <a:spcPts val="800"/>
-              </a:spcBef>
-              <a:spcAft>
-                <a:spcPts val="800"/>
-              </a:spcAft>
-              <a:defRPr sz="1800">
-                <a:solidFill>
-                  <a:srgbClr val="000000"/>
-                </a:solidFill>
-              </a:defRPr>
-            </a:pPr>
-            <a:r>
-              <a:t>  → IndexedDB (Browser Local Storage) for offline capability</a:t>
-            </a:r>
-          </a:p>
-          <a:p>
-            <a:pPr>
-              <a:spcBef>
-                <a:spcPts val="800"/>
-              </a:spcBef>
-              <a:spcAft>
-                <a:spcPts val="800"/>
-              </a:spcAft>
-              <a:defRPr sz="1800">
-                <a:solidFill>
-                  <a:srgbClr val="000000"/>
-                </a:solidFill>
-              </a:defRPr>
-            </a:pPr>
-          </a:p>
-          <a:p>
-            <a:pPr>
-              <a:spcBef>
-                <a:spcPts val="800"/>
-              </a:spcBef>
-              <a:spcAft>
-                <a:spcPts val="800"/>
-              </a:spcAft>
-              <a:defRPr sz="1800">
-                <a:solidFill>
-                  <a:srgbClr val="000000"/>
-                </a:solidFill>
-              </a:defRPr>
-            </a:pPr>
-            <a:r>
-              <a:t>Future: Server Backend for multi-user sync and cross-device access</a:t>
+              <a:t>  → React 18.2 + TypeScript for the inventory workflow UI</a:t>
+            </a:r>
+          </a:p>
+          <a:p>
+            <a:pPr>
+              <a:spcBef>
+                <a:spcPts val="800"/>
+              </a:spcBef>
+              <a:spcAft>
+                <a:spcPts val="800"/>
+              </a:spcAft>
+              <a:defRPr sz="1800">
+                <a:solidFill>
+                  <a:srgbClr val="000000"/>
+                </a:solidFill>
+              </a:defRPr>
+            </a:pPr>
+          </a:p>
+          <a:p>
+            <a:pPr>
+              <a:spcBef>
+                <a:spcPts val="800"/>
+              </a:spcBef>
+              <a:spcAft>
+                <a:spcPts val="800"/>
+              </a:spcAft>
+              <a:defRPr sz="1800">
+                <a:solidFill>
+                  <a:srgbClr val="000000"/>
+                </a:solidFill>
+              </a:defRPr>
+            </a:pPr>
+            <a:r>
+              <a:t>Auth &amp; Access Layer</a:t>
+            </a:r>
+          </a:p>
+          <a:p>
+            <a:pPr>
+              <a:spcBef>
+                <a:spcPts val="800"/>
+              </a:spcBef>
+              <a:spcAft>
+                <a:spcPts val="800"/>
+              </a:spcAft>
+              <a:defRPr sz="1800">
+                <a:solidFill>
+                  <a:srgbClr val="000000"/>
+                </a:solidFill>
+              </a:defRPr>
+            </a:pPr>
+            <a:r>
+              <a:t>  → Protected routes, admin approvals, and role-based access</a:t>
+            </a:r>
+          </a:p>
+          <a:p>
+            <a:pPr>
+              <a:spcBef>
+                <a:spcPts val="800"/>
+              </a:spcBef>
+              <a:spcAft>
+                <a:spcPts val="800"/>
+              </a:spcAft>
+              <a:defRPr sz="1800">
+                <a:solidFill>
+                  <a:srgbClr val="000000"/>
+                </a:solidFill>
+              </a:defRPr>
+            </a:pPr>
+          </a:p>
+          <a:p>
+            <a:pPr>
+              <a:spcBef>
+                <a:spcPts val="800"/>
+              </a:spcBef>
+              <a:spcAft>
+                <a:spcPts val="800"/>
+              </a:spcAft>
+              <a:defRPr sz="1800">
+                <a:solidFill>
+                  <a:srgbClr val="000000"/>
+                </a:solidFill>
+              </a:defRPr>
+            </a:pPr>
+            <a:r>
+              <a:t>Data Layer</a:t>
+            </a:r>
+          </a:p>
+          <a:p>
+            <a:pPr>
+              <a:spcBef>
+                <a:spcPts val="800"/>
+              </a:spcBef>
+              <a:spcAft>
+                <a:spcPts val="800"/>
+              </a:spcAft>
+              <a:defRPr sz="1800">
+                <a:solidFill>
+                  <a:srgbClr val="000000"/>
+                </a:solidFill>
+              </a:defRPr>
+            </a:pPr>
+            <a:r>
+              <a:t>  → Supabase for shared storage, with IndexedDB fallback when needed</a:t>
+            </a:r>
+          </a:p>
+          <a:p>
+            <a:pPr>
+              <a:spcBef>
+                <a:spcPts val="800"/>
+              </a:spcBef>
+              <a:spcAft>
+                <a:spcPts val="800"/>
+              </a:spcAft>
+              <a:defRPr sz="1800">
+                <a:solidFill>
+                  <a:srgbClr val="000000"/>
+                </a:solidFill>
+              </a:defRPr>
+            </a:pPr>
+          </a:p>
+          <a:p>
+            <a:pPr>
+              <a:spcBef>
+                <a:spcPts val="800"/>
+              </a:spcBef>
+              <a:spcAft>
+                <a:spcPts val="800"/>
+              </a:spcAft>
+              <a:defRPr sz="1800">
+                <a:solidFill>
+                  <a:srgbClr val="000000"/>
+                </a:solidFill>
+              </a:defRPr>
+            </a:pPr>
+            <a:r>
+              <a:t>Operations Layer</a:t>
+            </a:r>
+          </a:p>
+          <a:p>
+            <a:pPr>
+              <a:spcBef>
+                <a:spcPts val="800"/>
+              </a:spcBef>
+              <a:spcAft>
+                <a:spcPts val="800"/>
+              </a:spcAft>
+              <a:defRPr sz="1800">
+                <a:solidFill>
+                  <a:srgbClr val="000000"/>
+                </a:solidFill>
+              </a:defRPr>
+            </a:pPr>
+            <a:r>
+              <a:t>  → Excel import, reconciliation, tracking, and audit logging</a:t>
             </a:r>
           </a:p>
         </p:txBody>

</xml_diff>